<commit_message>
Fix night-warming line on climate route slide to match Jannat et al., 2026
The paper links AOD (not yield) more strongly to minimum temperature.

Co-Authored-By: Claude Opus 5.5 <noreply@anthropic.com>
Claude-Session: https://claude.ai/code/session_013ce4PKS59x4i27j5CRjVKQ
</commit_message>
<xml_diff>
--- a/seminar/Mechanisms_4_slides.pptx
+++ b/seminar/Mechanisms_4_slides.pptx
@@ -110,7 +110,7 @@
   <p:extLst>
     <p:ext uri="{521415D9-36F7-43E2-AB2F-B90AF26B5E84}">
       <p14:sectionLst xmlns:p14="http://schemas.microsoft.com/office/powerpoint/2010/main">
-        <p14:section name="6 · Mechanisms of aerosol impact" id="{3549895a-c5fe-276b-0746-e1a72cc8050c}">
+        <p14:section name="6 · Mechanisms of aerosol impact" id="{8cc2b670-880b-2f42-e640-3f8672a595fe}">
           <p14:sldIdLst>
             <p14:sldId id="256"/>
             <p14:sldId id="257"/>
@@ -615,7 +615,7 @@
             <a:r>
               <a:rPr lang="en-US" dirty="0"/>
               <a:t>Aerosol also changes productivity through climate, not only through light. Five pathways are shown.
-Leaf temperature: less sunlight cools leaves, as Steiner and Chameides, 2005, showed in their modelling. Whether this helps depends on how far the leaf is from the photosynthetic optimum of about 25 degrees Celsius; Yue and colleagues, 2017, found that in summer the aerosol-induced cooling brings leaf temperature closer to that optimum. Humidity: Zhang and colleagues, 2023, found that higher aerosol loading goes with lower vapour pressure deficit over cropland, grassland and mixed forest, and lower VPD enhances photosynthesis, so the vegetation response to aerosol is not only a diffuse-light effect. Soil moisture: less radiation means less evaporation, which keeps the soil wetter in the short term. Night temperature: in Bangladesh, Jannat and colleagues, 2026, found rice yields associated more strongly with minimum than with maximum temperature, pointing to night-time thermal change as a pathway. Monsoon rain: Auffhammer and colleagues, 2006, explain that brown clouds reduce rainfall because lower surface radiation reduces evaporation from the sea, and absorption in the lower atmosphere heats and stabilises it; India's rice harvest rises with June–September rainfall.
+Leaf temperature: less sunlight cools leaves, as Steiner and Chameides, 2005, showed in their modelling. Whether this helps depends on how far the leaf is from the photosynthetic optimum of about 25 degrees Celsius; Yue and colleagues, 2017, found that in summer the aerosol-induced cooling brings leaf temperature closer to that optimum. Humidity: Zhang and colleagues, 2023, found that higher aerosol loading goes with lower vapour pressure deficit over cropland, grassland and mixed forest, and lower VPD enhances photosynthesis, so the vegetation response to aerosol is not only a diffuse-light effect. Soil moisture: less radiation means less evaporation, which keeps the soil wetter in the short term. Night temperature: in Bangladesh, Jannat and colleagues, 2026, found that aerosol was more strongly associated with minimum temperature, with R squared up to 0.625, than with maximum temperature, suggesting that aerosol-induced night-time warming is an additional pathway alongside the photosynthetic response. Monsoon rain: Auffhammer and colleagues, 2006, explain that brown clouds reduce rainfall because lower surface radiation reduces evaporation from the sea, and absorption in the lower atmosphere heats and stabilises it; India's rice harvest rises with June–September rainfall.
 The chips give the only study that separates these routes, for China in 2010. Yue and colleagues, 2017, switched on one aerosol-driven change at a time in an Earth system model. Annual NPP rose by 0.09 petagrams of carbon through radiation, 0.07 through soil moisture and 0.03 through temperature, a total of about 0.20 petagrams or 5 percent. The figure shows the summer pattern of each pathway: total in panel a, temperature in b, PAR in c and soil moisture in d.
 But when aerosol effects on clouds were included, summer precipitation fell by 0.9 millimetres per day, or 13 percent, soil moisture fell, and the aerosol effect became a loss of 0.20 petagrams, or 4 percent. So, as the strip says, for rain-dependent ecosystems the rain route can outweigh the light route.</a:t>
             </a:r>
@@ -2894,7 +2894,7 @@
       </p:sp>
       <p:sp>
         <p:nvSpPr>
-          <p:cNvPr id="16" name="Night temperature pill"/>
+          <p:cNvPr id="16" name="Night warming pill"/>
           <p:cNvSpPr/>
           <p:nvPr/>
         </p:nvSpPr>
@@ -2921,7 +2921,7 @@
       </p:sp>
       <p:sp>
         <p:nvSpPr>
-          <p:cNvPr id="17" name="Night temperature label"/>
+          <p:cNvPr id="17" name="Night warming label"/>
           <p:cNvSpPr txBox="1"/>
           <p:nvPr/>
         </p:nvSpPr>
@@ -2949,15 +2949,15 @@
                   <a:srgbClr val="FFFFFF"/>
                 </a:solidFill>
               </a:rPr>
-              <a:t>Night temperature</a:t>
-            </a:r>
-            <a:endParaRPr lang="en-US" sz="1400" dirty="0"/>
-          </a:p>
-        </p:txBody>
-      </p:sp>
-      <p:sp>
-        <p:nvSpPr>
-          <p:cNvPr id="18" name="Night temperature text"/>
+              <a:t>Night warming</a:t>
+            </a:r>
+            <a:endParaRPr lang="en-US" sz="1400" dirty="0"/>
+          </a:p>
+        </p:txBody>
+      </p:sp>
+      <p:sp>
+        <p:nvSpPr>
+          <p:cNvPr id="18" name="Night warming text"/>
           <p:cNvSpPr txBox="1"/>
           <p:nvPr/>
         </p:nvSpPr>
@@ -2985,15 +2985,15 @@
                   <a:schemeClr val="tx1"/>
                 </a:solidFill>
               </a:rPr>
-              <a:t>Yield tracks minimum more than maximum temperature</a:t>
-            </a:r>
-            <a:endParaRPr lang="en-US" sz="1400" dirty="0"/>
-          </a:p>
-        </p:txBody>
-      </p:sp>
-      <p:sp>
-        <p:nvSpPr>
-          <p:cNvPr id="19" name="Night temperature ref"/>
+              <a:t>AOD tracks minimum more than maximum temperature</a:t>
+            </a:r>
+            <a:endParaRPr lang="en-US" sz="1400" dirty="0"/>
+          </a:p>
+        </p:txBody>
+      </p:sp>
+      <p:sp>
+        <p:nvSpPr>
+          <p:cNvPr id="19" name="Night warming ref"/>
           <p:cNvSpPr txBox="1"/>
           <p:nvPr/>
         </p:nvSpPr>

</xml_diff>

<commit_message>
Refine optimum-load slide wording and add figure captions
Sankhla result described as rise-then-saturate, Yue & Unger 0.4-0.6 marked
as site-study synthesis, Cohan aggregate curve captioned, strip cited.

Co-Authored-By: Claude Opus 5.5 <noreply@anthropic.com>
Claude-Session: https://claude.ai/code/session_013ce4PKS59x4i27j5CRjVKQ
</commit_message>
<xml_diff>
--- a/seminar/Mechanisms_4_slides.pptx
+++ b/seminar/Mechanisms_4_slides.pptx
@@ -110,7 +110,7 @@
   <p:extLst>
     <p:ext uri="{521415D9-36F7-43E2-AB2F-B90AF26B5E84}">
       <p14:sectionLst xmlns:p14="http://schemas.microsoft.com/office/powerpoint/2010/main">
-        <p14:section name="6 · Mechanisms of aerosol impact" id="{8cc2b670-880b-2f42-e640-3f8672a595fe}">
+        <p14:section name="6 · Mechanisms of aerosol impact" id="{c2295fe6-b4c4-02ed-27dc-83a43592212c}">
           <p14:sldIdLst>
             <p14:sldId id="256"/>
             <p14:sldId id="257"/>
@@ -706,7 +706,7 @@
             <a:r>
               <a:rPr lang="en-US" dirty="0"/>
               <a:t>Because dimming and diffuse fertilization pull in opposite directions, productivity follows an inverted-U response to aerosol: it rises at first, reaches a maximum and then falls.
-The card lists the reported optima. In the canopy model of Cohan and colleagues, 2002, for a mature soybean canopy on cloudless days, the maximum NPP enhancement of about 30 percent occurs at an AOD of about 0.6, and NPP declines somewhat above that. The left figure shows this: the open squares, for cloudless skies, rise and level off, while under overcast skies, where diffuse light is already high, aerosol only reduces NPP. For cropland in North China, Feng and colleagues, 2020, found that an AOD of 0.3 to 0.6, with a diffuse fraction around 30 to 40 percent, can largely increase total GPP. Across flux sites, Yue and Unger, 2018, found that photosynthesis reaches its maximum when the diffuse fraction is between 0.4 and 0.6, for both cloud and aerosol. In Punjab, Sankhla and colleagues found a significant non-linear relationship between AOD and wheat yield, with R squared of 0.90, with yield increasing up to an AOD of about 0.55; this is a preprint that is not yet peer reviewed. For India's ecological zones, Hari and Tyagi, 2022, found maximum NPP in forest ecosystems at an AOD of 0.38, with growth persisting up to 0.51, and in agroecosystems maximum growth at 0.49, with growth restricted by 0.59.
+The card lists the reported optima. In the canopy model of Cohan and colleagues, 2002, for a mature soybean canopy on cloudless days, the maximum NPP enhancement of about 30 percent occurs at an AOD of about 0.6, and NPP declines somewhat above that. The left figure, for 30 degrees north on 15 July, shows this: the open squares, for cloudless skies, rise and level off, while under cloud, with cloud optical depth 2 or 10, aerosol only reduces NPP because diffuse light is already high. The thick aggregate line assumes clear skies 40 percent of the time and thick cloud 60 percent of the time; it is essentially flat up to an AOD of 0.4 and then falls, by about 15 percent at an AOD of 1. For cropland in North China, Feng and colleagues, 2020, found that an AOD of 0.3 to 0.6, with a diffuse fraction around 30 to 40 percent, can largely increase total GPP. Yue and Unger, 2018, summarising site-level studies, note that photosynthesis reaches its maximum when the diffuse fraction is between 0.4 and 0.6, whether the diffuse light comes from cloud or aerosol. In Punjab, Sankhla and colleagues related binned AOD to wheat yield for 2000 to 2018: a second-order polynomial fits much better, with R squared of 0.90, than a straight line, with R squared of 0.64, and yield increases with AOD up to about 0.55 and thereafter saturates or decreases; this is a preprint that is not yet peer reviewed. For India's ecological zones, Hari and Tyagi, 2022, found maximum NPP in forest ecosystems at an AOD of 0.38, with growth persisting up to 0.51, and in agroecosystems maximum growth at 0.49, with growth restricted by 0.59.
 The reason for the optimum is in the strip. At low aerosol loading the gain from diffuse light grows faster than the loss of total light. Beyond the optimum, as Zhou and colleagues, 2022, explain, a further increase in diffuse fraction dampens GPP because photosynthesis of the sunlit leaves falls, and total light becomes limiting.</a:t>
             </a:r>
             <a:endParaRPr lang="en-US" dirty="0"/>
@@ -4213,7 +4213,7 @@
                   <a:schemeClr val="tx1"/>
                 </a:solidFill>
               </a:rPr>
-              <a:t> photosynthesis maximum</a:t>
+              <a:t> photosynthesis maximum in site studies</a:t>
             </a:r>
             <a:endParaRPr lang="en-US" sz="1400" dirty="0"/>
           </a:p>
@@ -4254,7 +4254,7 @@
                   <a:schemeClr val="tx1"/>
                 </a:solidFill>
               </a:rPr>
-              <a:t> Punjab wheat yield peak (R² = 0.90)</a:t>
+              <a:t> Punjab wheat yield rises, then saturates (R² = 0.90)</a:t>
             </a:r>
             <a:endParaRPr lang="en-US" sz="1400" dirty="0"/>
           </a:p>
@@ -4366,11 +4366,11 @@
         <p:spPr>
           <a:xfrm>
             <a:off x="5532120" y="1280160"/>
-            <a:ext cx="3291840" cy="2965901"/>
+            <a:ext cx="3291840" cy="3423101"/>
           </a:xfrm>
           <a:prstGeom prst="roundRect">
             <a:avLst>
-              <a:gd name="adj" fmla="val 2158"/>
+              <a:gd name="adj" fmla="val 1944"/>
             </a:avLst>
           </a:prstGeom>
           <a:solidFill>
@@ -4455,13 +4455,49 @@
       </p:pic>
       <p:sp>
         <p:nvSpPr>
-          <p:cNvPr id="10" name="Cohan figure source"/>
+          <p:cNvPr id="10" name="Cohan figure caption"/>
           <p:cNvSpPr txBox="1"/>
           <p:nvPr/>
         </p:nvSpPr>
         <p:spPr>
           <a:xfrm>
             <a:off x="5669280" y="3889445"/>
+            <a:ext cx="3017520" cy="457200"/>
+          </a:xfrm>
+          <a:prstGeom prst="rect">
+            <a:avLst/>
+          </a:prstGeom>
+          <a:noFill/>
+          <a:ln/>
+        </p:spPr>
+        <p:txBody>
+          <a:bodyPr wrap="square" lIns="0" tIns="0" rIns="0" bIns="0" rtlCol="0" anchor="t"/>
+          <a:lstStyle/>
+          <a:p>
+            <a:pPr indent="0" marL="0">
+              <a:buNone/>
+            </a:pPr>
+            <a:r>
+              <a:rPr lang="en-US" sz="1400" dirty="0">
+                <a:solidFill>
+                  <a:schemeClr val="tx1"/>
+                </a:solidFill>
+              </a:rPr>
+              <a:t>Aggregate (40% clear, 60% overcast): flat to AOD 0.4, then falls</a:t>
+            </a:r>
+            <a:endParaRPr lang="en-US" sz="1400" dirty="0"/>
+          </a:p>
+        </p:txBody>
+      </p:sp>
+      <p:sp>
+        <p:nvSpPr>
+          <p:cNvPr id="11" name="Cohan figure source"/>
+          <p:cNvSpPr txBox="1"/>
+          <p:nvPr/>
+        </p:nvSpPr>
+        <p:spPr>
+          <a:xfrm>
+            <a:off x="5669280" y="4346645"/>
             <a:ext cx="3017520" cy="246888"/>
           </a:xfrm>
           <a:prstGeom prst="rect">
@@ -4491,14 +4527,14 @@
       </p:sp>
       <p:sp>
         <p:nvSpPr>
-          <p:cNvPr id="11" name="Sankhla figure card"/>
+          <p:cNvPr id="12" name="Sankhla figure card"/>
           <p:cNvSpPr/>
           <p:nvPr/>
         </p:nvSpPr>
         <p:spPr>
           <a:xfrm>
             <a:off x="9006840" y="1280160"/>
-            <a:ext cx="2724912" cy="3132389"/>
+            <a:ext cx="2724912" cy="3611880"/>
           </a:xfrm>
           <a:prstGeom prst="roundRect">
             <a:avLst>
@@ -4527,14 +4563,14 @@
       </p:sp>
       <p:sp>
         <p:nvSpPr>
-          <p:cNvPr id="12" name="Sankhla figure title"/>
+          <p:cNvPr id="13" name="Sankhla figure title"/>
           <p:cNvSpPr txBox="1"/>
           <p:nvPr/>
         </p:nvSpPr>
         <p:spPr>
           <a:xfrm>
             <a:off x="9144000" y="1371600"/>
-            <a:ext cx="2450592" cy="301752"/>
+            <a:ext cx="2450592" cy="530352"/>
           </a:xfrm>
           <a:prstGeom prst="rect">
             <a:avLst/>
@@ -4555,7 +4591,7 @@
                   <a:schemeClr val="tx2"/>
                 </a:solidFill>
               </a:rPr>
-              <a:t>Punjab wheat yield vs AOD</a:t>
+              <a:t>Punjab wheat yield vs AOD, 2000–2018</a:t>
             </a:r>
             <a:endParaRPr lang="en-US" sz="1400" dirty="0"/>
           </a:p>
@@ -4563,7 +4599,7 @@
       </p:sp>
       <p:pic>
         <p:nvPicPr>
-          <p:cNvPr id="13" name="Sankhla figure" descr="Sankhla figure">    </p:cNvPr>
+          <p:cNvPr id="14" name="Sankhla figure" descr="Sankhla figure">    </p:cNvPr>
           <p:cNvPicPr>
             <a:picLocks noChangeAspect="1"/>
           </p:cNvPicPr>
@@ -4577,8 +4613,8 @@
         </p:blipFill>
         <p:spPr>
           <a:xfrm>
-            <a:off x="9226296" y="1673352"/>
-            <a:ext cx="2286000" cy="2309429"/>
+            <a:off x="9328404" y="1901952"/>
+            <a:ext cx="2081784" cy="2103120"/>
           </a:xfrm>
           <a:prstGeom prst="rect">
             <a:avLst/>
@@ -4587,13 +4623,49 @@
       </p:pic>
       <p:sp>
         <p:nvSpPr>
-          <p:cNvPr id="14" name="Sankhla figure source"/>
-          <p:cNvSpPr txBox="1"/>
-          <p:nvPr/>
-        </p:nvSpPr>
-        <p:spPr>
-          <a:xfrm>
-            <a:off x="9144000" y="4055933"/>
+          <p:cNvPr id="15" name="Sankhla figure caption"/>
+          <p:cNvSpPr txBox="1"/>
+          <p:nvPr/>
+        </p:nvSpPr>
+        <p:spPr>
+          <a:xfrm>
+            <a:off x="9144000" y="4078224"/>
+            <a:ext cx="2450592" cy="457200"/>
+          </a:xfrm>
+          <a:prstGeom prst="rect">
+            <a:avLst/>
+          </a:prstGeom>
+          <a:noFill/>
+          <a:ln/>
+        </p:spPr>
+        <p:txBody>
+          <a:bodyPr wrap="square" lIns="0" tIns="0" rIns="0" bIns="0" rtlCol="0" anchor="t"/>
+          <a:lstStyle/>
+          <a:p>
+            <a:pPr indent="0" marL="0">
+              <a:buNone/>
+            </a:pPr>
+            <a:r>
+              <a:rPr lang="en-US" sz="1400" dirty="0">
+                <a:solidFill>
+                  <a:schemeClr val="tx1"/>
+                </a:solidFill>
+              </a:rPr>
+              <a:t>Red: quadratic fit; black: linear (R² = 0.64)</a:t>
+            </a:r>
+            <a:endParaRPr lang="en-US" sz="1400" dirty="0"/>
+          </a:p>
+        </p:txBody>
+      </p:sp>
+      <p:sp>
+        <p:nvSpPr>
+          <p:cNvPr id="16" name="Sankhla figure source"/>
+          <p:cNvSpPr txBox="1"/>
+          <p:nvPr/>
+        </p:nvSpPr>
+        <p:spPr>
+          <a:xfrm>
+            <a:off x="9144000" y="4535424"/>
             <a:ext cx="2450592" cy="246888"/>
           </a:xfrm>
           <a:prstGeom prst="rect">
@@ -4623,7 +4695,7 @@
       </p:sp>
       <p:sp>
         <p:nvSpPr>
-          <p:cNvPr id="15" name="Optimum strip"/>
+          <p:cNvPr id="17" name="Optimum strip"/>
           <p:cNvSpPr/>
           <p:nvPr/>
         </p:nvSpPr>
@@ -4650,7 +4722,7 @@
       </p:sp>
       <p:sp>
         <p:nvSpPr>
-          <p:cNvPr id="16" name="Optimum strip text"/>
+          <p:cNvPr id="18" name="Optimum strip text"/>
           <p:cNvSpPr txBox="1"/>
           <p:nvPr/>
         </p:nvSpPr>
@@ -4686,7 +4758,7 @@
                   <a:schemeClr val="tx1"/>
                 </a:solidFill>
               </a:rPr>
-              <a:t> diffuse gain rises with AOD at first; beyond the optimum, the loss of total light and of sunlit‑leaf photosynthesis dominates.</a:t>
+              <a:t> diffuse gain rises with AOD at first; beyond it, loss of total light and sunlit‑leaf photosynthesis dominates (Zhou et al., 2022)</a:t>
             </a:r>
             <a:endParaRPr lang="en-US" sz="1400" dirty="0"/>
           </a:p>

</xml_diff>